<commit_message>
Put Heena’s photos into the freshman-share PowerPoint
Use the uploaded conference, metro volunteer, ESL, and culture-festival
photographs on the experience slides, and add a gallery page for the rest.

Co-authored-by: kristinehina23-rgb <kristinehina23-rgb@users.noreply.github.com>
</commit_message>
<xml_diff>
--- a/freshman-share-2026/Heena-SYSU-Freshman-Share-2026.pptx
+++ b/freshman-share-2026/Heena-SYSU-Freshman-Share-2026.pptx
@@ -13,6 +13,7 @@
     <p:sldId id="261" r:id="rId13"/>
     <p:sldId id="262" r:id="rId14"/>
     <p:sldId id="263" r:id="rId15"/>
+    <p:sldId id="264" r:id="rId16"/>
   </p:sldIdLst>
   <p:sldSz cx="12191999" cy="6858000" type="screen4x3"/>
   <p:notesSz cx="6858000" cy="9144000"/>
@@ -962,7 +963,7 @@
           <a:lstStyle/>
           <a:p>
             <a:r>
-              <a:t>收束到新生可以立刻做的三件事，避免空泛鸡汤。</a:t>
+              <a:t>补充现场：地铁站台、护苗课堂、本原讲堂结业、课堂表达、文化交流手绘、中大春节装置、中国传统服饰体验。</a:t>
             </a:r>
           </a:p>
         </p:txBody>
@@ -988,6 +989,76 @@
 </file>
 
 <file path=ppt/notesSlides/notesSlide8.xml><?xml version="1.0" encoding="utf-8"?>
+<p:notes xmlns:a="http://schemas.openxmlformats.org/drawingml/2006/main" xmlns:p="http://schemas.openxmlformats.org/presentationml/2006/main" xmlns:r="http://schemas.openxmlformats.org/officeDocument/2006/relationships">
+  <p:cSld>
+    <p:spTree>
+      <p:nvGrpSpPr>
+        <p:cNvPr id="1" name=""/>
+        <p:cNvGrpSpPr/>
+        <p:nvPr/>
+      </p:nvGrpSpPr>
+      <p:grpSpPr>
+        <a:xfrm>
+          <a:off x="0" y="0"/>
+          <a:ext cx="0" cy="0"/>
+          <a:chOff x="0" y="0"/>
+          <a:chExt cx="0" cy="0"/>
+        </a:xfrm>
+      </p:grpSpPr>
+      <p:sp>
+        <p:nvSpPr>
+          <p:cNvPr id="2" name="Slide Image Placeholder 1"/>
+          <p:cNvSpPr>
+            <a:spLocks noGrp="1"/>
+          </p:cNvSpPr>
+          <p:nvPr>
+            <p:ph type="sldImg" idx="2"/>
+          </p:nvPr>
+        </p:nvSpPr>
+        <p:spPr/>
+      </p:sp>
+      <p:sp>
+        <p:nvSpPr>
+          <p:cNvPr id="3" name="Notes Placeholder 2"/>
+          <p:cNvSpPr>
+            <a:spLocks noGrp="1"/>
+          </p:cNvSpPr>
+          <p:nvPr>
+            <p:ph type="body" idx="3" sz="quarter"/>
+          </p:nvPr>
+        </p:nvSpPr>
+        <p:spPr/>
+        <p:txBody>
+          <a:bodyPr/>
+          <a:lstStyle/>
+          <a:p>
+            <a:r>
+              <a:t>收束到新生可以立刻做的三件事，避免空泛鸡汤。</a:t>
+            </a:r>
+          </a:p>
+        </p:txBody>
+      </p:sp>
+      <p:sp>
+        <p:nvSpPr>
+          <p:cNvPr id="4" name="Slide Number Placeholder 3"/>
+          <p:cNvSpPr>
+            <a:spLocks noGrp="1"/>
+          </p:cNvSpPr>
+          <p:nvPr>
+            <p:ph type="sldNum" idx="5" sz="quarter"/>
+          </p:nvPr>
+        </p:nvSpPr>
+        <p:spPr/>
+      </p:sp>
+    </p:spTree>
+  </p:cSld>
+  <p:clrMapOvr>
+    <a:masterClrMapping/>
+  </p:clrMapOvr>
+</p:notes>
+</file>
+
+<file path=ppt/notesSlides/notesSlide9.xml><?xml version="1.0" encoding="utf-8"?>
 <p:notes xmlns:a="http://schemas.openxmlformats.org/drawingml/2006/main" xmlns:p="http://schemas.openxmlformats.org/presentationml/2006/main" xmlns:r="http://schemas.openxmlformats.org/officeDocument/2006/relationships">
   <p:cSld>
     <p:spTree>
@@ -4335,6 +4406,48 @@
       <p:pic>
         <p:nvPicPr>
           <p:cNvPr id="2" name="slide-08" descr="image.jpg"/>
+          <p:cNvPicPr>
+            <a:picLocks noChangeAspect="1"/>
+          </p:cNvPicPr>
+          <p:nvPr/>
+        </p:nvPicPr>
+        <p:blipFill>
+          <a:blip r:embed="rId2"/>
+          <a:stretch>
+            <a:fillRect/>
+          </a:stretch>
+        </p:blipFill>
+        <p:spPr>
+          <a:xfrm>
+            <a:off x="0" y="0"/>
+            <a:ext cx="12191999" cy="6858000"/>
+          </a:xfrm>
+          <a:prstGeom prst="rect">
+            <a:avLst/>
+          </a:prstGeom>
+        </p:spPr>
+      </p:pic>
+    </p:spTree>
+  </p:cSld>
+  <p:clrMapOvr>
+    <a:masterClrMapping/>
+  </p:clrMapOvr>
+</p:sld>
+</file>
+
+<file path=ppt/slides/slide9.xml><?xml version="1.0" encoding="utf-8"?>
+<p:sld xmlns:a="http://schemas.openxmlformats.org/drawingml/2006/main" xmlns:p="http://schemas.openxmlformats.org/presentationml/2006/main" xmlns:r="http://schemas.openxmlformats.org/officeDocument/2006/relationships">
+  <p:cSld>
+    <p:spTree>
+      <p:nvGrpSpPr>
+        <p:cNvPr id="1" name=""/>
+        <p:cNvGrpSpPr/>
+        <p:nvPr/>
+      </p:nvGrpSpPr>
+      <p:grpSpPr/>
+      <p:pic>
+        <p:nvPicPr>
+          <p:cNvPr id="2" name="slide-09" descr="image.jpg"/>
           <p:cNvPicPr>
             <a:picLocks noChangeAspect="1"/>
           </p:cNvPicPr>

</xml_diff>

<commit_message>
Add slides on continuing study in China for international students
Cover official SYSU and CSC channels, plus four undergraduate
preparations: language, materials, research direction, and timelines.

Co-authored-by: kristinehina23-rgb <kristinehina23-rgb@users.noreply.github.com>
</commit_message>
<xml_diff>
--- a/freshman-share-2026/Heena-SYSU-Freshman-Share-2026.pptx
+++ b/freshman-share-2026/Heena-SYSU-Freshman-Share-2026.pptx
@@ -14,6 +14,8 @@
     <p:sldId id="262" r:id="rId14"/>
     <p:sldId id="263" r:id="rId15"/>
     <p:sldId id="264" r:id="rId16"/>
+    <p:sldId id="265" r:id="rId17"/>
+    <p:sldId id="266" r:id="rId18"/>
   </p:sldIdLst>
   <p:sldSz cx="12191999" cy="6858000" type="screen4x3"/>
   <p:notesSz cx="6858000" cy="9144000"/>
@@ -535,6 +537,146 @@
 </p:notes>
 </file>
 
+<file path=ppt/notesSlides/notesSlide10.xml><?xml version="1.0" encoding="utf-8"?>
+<p:notes xmlns:a="http://schemas.openxmlformats.org/drawingml/2006/main" xmlns:p="http://schemas.openxmlformats.org/presentationml/2006/main" xmlns:r="http://schemas.openxmlformats.org/officeDocument/2006/relationships">
+  <p:cSld>
+    <p:spTree>
+      <p:nvGrpSpPr>
+        <p:cNvPr id="1" name=""/>
+        <p:cNvGrpSpPr/>
+        <p:nvPr/>
+      </p:nvGrpSpPr>
+      <p:grpSpPr>
+        <a:xfrm>
+          <a:off x="0" y="0"/>
+          <a:ext cx="0" cy="0"/>
+          <a:chOff x="0" y="0"/>
+          <a:chExt cx="0" cy="0"/>
+        </a:xfrm>
+      </p:grpSpPr>
+      <p:sp>
+        <p:nvSpPr>
+          <p:cNvPr id="2" name="Slide Image Placeholder 1"/>
+          <p:cNvSpPr>
+            <a:spLocks noGrp="1"/>
+          </p:cNvSpPr>
+          <p:nvPr>
+            <p:ph type="sldImg" idx="2"/>
+          </p:nvPr>
+        </p:nvSpPr>
+        <p:spPr/>
+      </p:sp>
+      <p:sp>
+        <p:nvSpPr>
+          <p:cNvPr id="3" name="Notes Placeholder 2"/>
+          <p:cNvSpPr>
+            <a:spLocks noGrp="1"/>
+          </p:cNvSpPr>
+          <p:nvPr>
+            <p:ph type="body" idx="3" sz="quarter"/>
+          </p:nvPr>
+        </p:nvSpPr>
+        <p:spPr/>
+        <p:txBody>
+          <a:bodyPr/>
+          <a:lstStyle/>
+          <a:p>
+            <a:r>
+              <a:t>收束到新生可以立刻做的三件事，避免空泛鸡汤。</a:t>
+            </a:r>
+          </a:p>
+        </p:txBody>
+      </p:sp>
+      <p:sp>
+        <p:nvSpPr>
+          <p:cNvPr id="4" name="Slide Number Placeholder 3"/>
+          <p:cNvSpPr>
+            <a:spLocks noGrp="1"/>
+          </p:cNvSpPr>
+          <p:nvPr>
+            <p:ph type="sldNum" idx="5" sz="quarter"/>
+          </p:nvPr>
+        </p:nvSpPr>
+        <p:spPr/>
+      </p:sp>
+    </p:spTree>
+  </p:cSld>
+  <p:clrMapOvr>
+    <a:masterClrMapping/>
+  </p:clrMapOvr>
+</p:notes>
+</file>
+
+<file path=ppt/notesSlides/notesSlide11.xml><?xml version="1.0" encoding="utf-8"?>
+<p:notes xmlns:a="http://schemas.openxmlformats.org/drawingml/2006/main" xmlns:p="http://schemas.openxmlformats.org/presentationml/2006/main" xmlns:r="http://schemas.openxmlformats.org/officeDocument/2006/relationships">
+  <p:cSld>
+    <p:spTree>
+      <p:nvGrpSpPr>
+        <p:cNvPr id="1" name=""/>
+        <p:cNvGrpSpPr/>
+        <p:nvPr/>
+      </p:nvGrpSpPr>
+      <p:grpSpPr>
+        <a:xfrm>
+          <a:off x="0" y="0"/>
+          <a:ext cx="0" cy="0"/>
+          <a:chOff x="0" y="0"/>
+          <a:chExt cx="0" cy="0"/>
+        </a:xfrm>
+      </p:grpSpPr>
+      <p:sp>
+        <p:nvSpPr>
+          <p:cNvPr id="2" name="Slide Image Placeholder 1"/>
+          <p:cNvSpPr>
+            <a:spLocks noGrp="1"/>
+          </p:cNvSpPr>
+          <p:nvPr>
+            <p:ph type="sldImg" idx="2"/>
+          </p:nvPr>
+        </p:nvSpPr>
+        <p:spPr/>
+      </p:sp>
+      <p:sp>
+        <p:nvSpPr>
+          <p:cNvPr id="3" name="Notes Placeholder 2"/>
+          <p:cNvSpPr>
+            <a:spLocks noGrp="1"/>
+          </p:cNvSpPr>
+          <p:nvPr>
+            <p:ph type="body" idx="3" sz="quarter"/>
+          </p:nvPr>
+        </p:nvSpPr>
+        <p:spPr/>
+        <p:txBody>
+          <a:bodyPr/>
+          <a:lstStyle/>
+          <a:p>
+            <a:r>
+              <a:t>结束：欢迎提问。强调可靠、在场和互相理解。</a:t>
+            </a:r>
+          </a:p>
+        </p:txBody>
+      </p:sp>
+      <p:sp>
+        <p:nvSpPr>
+          <p:cNvPr id="4" name="Slide Number Placeholder 3"/>
+          <p:cNvSpPr>
+            <a:spLocks noGrp="1"/>
+          </p:cNvSpPr>
+          <p:nvPr>
+            <p:ph type="sldNum" idx="5" sz="quarter"/>
+          </p:nvPr>
+        </p:nvSpPr>
+        <p:spPr/>
+      </p:sp>
+    </p:spTree>
+  </p:cSld>
+  <p:clrMapOvr>
+    <a:masterClrMapping/>
+  </p:clrMapOvr>
+</p:notes>
+</file>
+
 <file path=ppt/notesSlides/notesSlide2.xml><?xml version="1.0" encoding="utf-8"?>
 <p:notes xmlns:a="http://schemas.openxmlformats.org/drawingml/2006/main" xmlns:p="http://schemas.openxmlformats.org/presentationml/2006/main" xmlns:r="http://schemas.openxmlformats.org/officeDocument/2006/relationships">
   <p:cSld>
@@ -1033,7 +1175,33 @@
           <a:lstStyle/>
           <a:p>
             <a:r>
-              <a:t>收束到新生可以立刻做的三件事，避免空泛鸡汤。</a:t>
+              <a:t>升学渠道只讲官方入口，并提醒以当年简章为准。</a:t>
+            </a:r>
+          </a:p>
+          <a:p/>
+          <a:p>
+            <a:r>
+              <a:t>[Sources]</a:t>
+            </a:r>
+          </a:p>
+          <a:p>
+            <a:r>
+              <a:t>- 中山大学外国留学生办公室 https://iso.sysu.edu.cn</a:t>
+            </a:r>
+          </a:p>
+          <a:p>
+            <a:r>
+              <a:t>- 中山大学国际学生报名系统 https://apply.sysu.edu.cn</a:t>
+            </a:r>
+          </a:p>
+          <a:p>
+            <a:r>
+              <a:t>- 中国政府奖学金来华留学管理信息系统 http://studyinchina.csc.edu.cn / https://www.campuschina.org</a:t>
+            </a:r>
+          </a:p>
+          <a:p>
+            <a:r>
+              <a:t>- 中大机构代码 10558；咨询 admissions@mail.sysu.edu.cn，+86-20-84110819</a:t>
             </a:r>
           </a:p>
         </p:txBody>
@@ -1103,7 +1271,23 @@
           <a:lstStyle/>
           <a:p>
             <a:r>
-              <a:t>结束：欢迎提问。强调可靠、在场和互相理解。</a:t>
+              <a:t>强调本科阶段就能开始的准备，不把某一年的报名批次说成固定时间。</a:t>
+            </a:r>
+          </a:p>
+          <a:p/>
+          <a:p>
+            <a:r>
+              <a:t>[Sources]</a:t>
+            </a:r>
+          </a:p>
+          <a:p>
+            <a:r>
+              <a:t>- 中山大学国际学生硕士/博士招生简章（外国留学生办公室公布）</a:t>
+            </a:r>
+          </a:p>
+          <a:p>
+            <a:r>
+              <a:t>- 学信网 https://www.chsi.com.cn 学历学位验证要求</a:t>
             </a:r>
           </a:p>
         </p:txBody>
@@ -4112,6 +4296,90 @@
       <p:pic>
         <p:nvPicPr>
           <p:cNvPr id="2" name="slide-01" descr="image.jpg"/>
+          <p:cNvPicPr>
+            <a:picLocks noChangeAspect="1"/>
+          </p:cNvPicPr>
+          <p:nvPr/>
+        </p:nvPicPr>
+        <p:blipFill>
+          <a:blip r:embed="rId2"/>
+          <a:stretch>
+            <a:fillRect/>
+          </a:stretch>
+        </p:blipFill>
+        <p:spPr>
+          <a:xfrm>
+            <a:off x="0" y="0"/>
+            <a:ext cx="12191999" cy="6858000"/>
+          </a:xfrm>
+          <a:prstGeom prst="rect">
+            <a:avLst/>
+          </a:prstGeom>
+        </p:spPr>
+      </p:pic>
+    </p:spTree>
+  </p:cSld>
+  <p:clrMapOvr>
+    <a:masterClrMapping/>
+  </p:clrMapOvr>
+</p:sld>
+</file>
+
+<file path=ppt/slides/slide10.xml><?xml version="1.0" encoding="utf-8"?>
+<p:sld xmlns:a="http://schemas.openxmlformats.org/drawingml/2006/main" xmlns:p="http://schemas.openxmlformats.org/presentationml/2006/main" xmlns:r="http://schemas.openxmlformats.org/officeDocument/2006/relationships">
+  <p:cSld>
+    <p:spTree>
+      <p:nvGrpSpPr>
+        <p:cNvPr id="1" name=""/>
+        <p:cNvGrpSpPr/>
+        <p:nvPr/>
+      </p:nvGrpSpPr>
+      <p:grpSpPr/>
+      <p:pic>
+        <p:nvPicPr>
+          <p:cNvPr id="2" name="slide-10" descr="image.jpg"/>
+          <p:cNvPicPr>
+            <a:picLocks noChangeAspect="1"/>
+          </p:cNvPicPr>
+          <p:nvPr/>
+        </p:nvPicPr>
+        <p:blipFill>
+          <a:blip r:embed="rId2"/>
+          <a:stretch>
+            <a:fillRect/>
+          </a:stretch>
+        </p:blipFill>
+        <p:spPr>
+          <a:xfrm>
+            <a:off x="0" y="0"/>
+            <a:ext cx="12191999" cy="6858000"/>
+          </a:xfrm>
+          <a:prstGeom prst="rect">
+            <a:avLst/>
+          </a:prstGeom>
+        </p:spPr>
+      </p:pic>
+    </p:spTree>
+  </p:cSld>
+  <p:clrMapOvr>
+    <a:masterClrMapping/>
+  </p:clrMapOvr>
+</p:sld>
+</file>
+
+<file path=ppt/slides/slide11.xml><?xml version="1.0" encoding="utf-8"?>
+<p:sld xmlns:a="http://schemas.openxmlformats.org/drawingml/2006/main" xmlns:p="http://schemas.openxmlformats.org/presentationml/2006/main" xmlns:r="http://schemas.openxmlformats.org/officeDocument/2006/relationships">
+  <p:cSld>
+    <p:spTree>
+      <p:nvGrpSpPr>
+        <p:cNvPr id="1" name=""/>
+        <p:cNvGrpSpPr/>
+        <p:nvPr/>
+      </p:nvGrpSpPr>
+      <p:grpSpPr/>
+      <p:pic>
+        <p:nvPicPr>
+          <p:cNvPr id="2" name="slide-11" descr="image.jpg"/>
           <p:cNvPicPr>
             <a:picLocks noChangeAspect="1"/>
           </p:cNvPicPr>

</xml_diff>